<commit_message>
Add live demo URL to slides; stop tracking deliverable build scripts
</commit_message>
<xml_diff>
--- a/Movie_Recommender_Individual_Project.pptx
+++ b/Movie_Recommender_Individual_Project.pptx
@@ -3166,7 +3166,7 @@
         <p:spPr>
           <a:xfrm>
             <a:off x="868680" y="4572000"/>
-            <a:ext cx="10515600" cy="1463040"/>
+            <a:ext cx="10515600" cy="1828800"/>
           </a:xfrm>
           <a:prstGeom prst="rect">
             <a:avLst/>
@@ -3212,6 +3212,18 @@
             </a:pPr>
             <a:r>
               <a:t>June 2026</a:t>
+            </a:r>
+          </a:p>
+          <a:p>
+            <a:pPr>
+              <a:defRPr sz="1400">
+                <a:solidFill>
+                  <a:srgbClr val="C7D2EC"/>
+                </a:solidFill>
+              </a:defRPr>
+            </a:pPr>
+            <a:r>
+              <a:t>Live demo: https://movie-recommender-systems-bgvfxcjsf7myfvfxjyircb.streamlit.app</a:t>
             </a:r>
           </a:p>
         </p:txBody>
@@ -5037,7 +5049,7 @@
               <a:spcAft>
                 <a:spcPts val="800"/>
               </a:spcAft>
-              <a:defRPr sz="1800" b="1">
+              <a:defRPr sz="1700" b="1">
                 <a:solidFill>
                   <a:srgbClr val="2E6FF2"/>
                 </a:solidFill>
@@ -5052,7 +5064,7 @@
               <a:spcAft>
                 <a:spcPts val="800"/>
               </a:spcAft>
-              <a:defRPr sz="1600" b="0">
+              <a:defRPr sz="1500" b="0">
                 <a:solidFill>
                   <a:srgbClr val="1F2A44"/>
                 </a:solidFill>
@@ -5067,7 +5079,7 @@
               <a:spcAft>
                 <a:spcPts val="800"/>
               </a:spcAft>
-              <a:defRPr sz="1600" b="0">
+              <a:defRPr sz="1500" b="0">
                 <a:solidFill>
                   <a:srgbClr val="1F2A44"/>
                 </a:solidFill>
@@ -5082,7 +5094,7 @@
               <a:spcAft>
                 <a:spcPts val="800"/>
               </a:spcAft>
-              <a:defRPr sz="1600" b="0">
+              <a:defRPr sz="1500" b="0">
                 <a:solidFill>
                   <a:srgbClr val="1F2A44"/>
                 </a:solidFill>
@@ -5097,7 +5109,7 @@
               <a:spcAft>
                 <a:spcPts val="800"/>
               </a:spcAft>
-              <a:defRPr sz="1800" b="1">
+              <a:defRPr sz="1700" b="1">
                 <a:solidFill>
                   <a:srgbClr val="2E6FF2"/>
                 </a:solidFill>
@@ -5112,7 +5124,7 @@
               <a:spcAft>
                 <a:spcPts val="800"/>
               </a:spcAft>
-              <a:defRPr sz="1600" b="0">
+              <a:defRPr sz="1500" b="0">
                 <a:solidFill>
                   <a:srgbClr val="1F2A44"/>
                 </a:solidFill>
@@ -5127,7 +5139,7 @@
               <a:spcAft>
                 <a:spcPts val="800"/>
               </a:spcAft>
-              <a:defRPr sz="1800" b="1">
+              <a:defRPr sz="1700" b="1">
                 <a:solidFill>
                   <a:srgbClr val="2E6FF2"/>
                 </a:solidFill>
@@ -5142,7 +5154,7 @@
               <a:spcAft>
                 <a:spcPts val="800"/>
               </a:spcAft>
-              <a:defRPr sz="1600" b="0">
+              <a:defRPr sz="1500" b="0">
                 <a:solidFill>
                   <a:srgbClr val="1F2A44"/>
                 </a:solidFill>
@@ -5157,14 +5169,29 @@
               <a:spcAft>
                 <a:spcPts val="800"/>
               </a:spcAft>
-              <a:defRPr sz="1800" b="1">
+              <a:defRPr sz="1700" b="1">
+                <a:solidFill>
+                  <a:srgbClr val="2E6FF2"/>
+                </a:solidFill>
+              </a:defRPr>
+            </a:pPr>
+            <a:r>
+              <a:t>Live app:  https://movie-recommender-systems-bgvfxcjsf7myfvfxjyircb.streamlit.app</a:t>
+            </a:r>
+          </a:p>
+          <a:p>
+            <a:pPr>
+              <a:spcAft>
+                <a:spcPts val="800"/>
+              </a:spcAft>
+              <a:defRPr sz="1700" b="1">
                 <a:solidFill>
                   <a:srgbClr val="555E6E"/>
                 </a:solidFill>
               </a:defRPr>
             </a:pPr>
             <a:r>
-              <a:t>Run:  python build_artifacts.py    →    streamlit run app.py</a:t>
+              <a:t>Run locally:  python build_artifacts.py  →  streamlit run app.py</a:t>
             </a:r>
           </a:p>
         </p:txBody>

</xml_diff>